<commit_message>
Final Presentation of the CA 2
</commit_message>
<xml_diff>
--- a/Final Presentation.pptx
+++ b/Final Presentation.pptx
@@ -18,8 +18,9 @@
     <p:sldId id="266" r:id="rId12"/>
     <p:sldId id="267" r:id="rId13"/>
     <p:sldId id="268" r:id="rId14"/>
-    <p:sldId id="269" r:id="rId15"/>
-    <p:sldId id="270" r:id="rId16"/>
+    <p:sldId id="271" r:id="rId15"/>
+    <p:sldId id="269" r:id="rId16"/>
+    <p:sldId id="270" r:id="rId17"/>
   </p:sldIdLst>
   <p:sldSz cx="12192000" cy="6858000"/>
   <p:notesSz cx="6858000" cy="9144000"/>
@@ -9721,6 +9722,56 @@
             </a:r>
           </a:p>
           <a:p>
+            <a:r>
+              <a:rPr lang="en-US" sz="1600" dirty="0" smtClean="0">
+                <a:latin typeface="Tahoma" panose="020B0604030504040204" pitchFamily="34" charset="0"/>
+                <a:ea typeface="Tahoma" panose="020B0604030504040204" pitchFamily="34" charset="0"/>
+                <a:cs typeface="Tahoma" panose="020B0604030504040204" pitchFamily="34" charset="0"/>
+              </a:rPr>
+              <a:t>Why use Hybrid Database</a:t>
+            </a:r>
+          </a:p>
+          <a:p>
+            <a:pPr lvl="1"/>
+            <a:r>
+              <a:rPr lang="en-US" sz="1400" dirty="0">
+                <a:latin typeface="Tahoma" panose="020B0604030504040204" pitchFamily="34" charset="0"/>
+                <a:ea typeface="Tahoma" panose="020B0604030504040204" pitchFamily="34" charset="0"/>
+                <a:cs typeface="Tahoma" panose="020B0604030504040204" pitchFamily="34" charset="0"/>
+              </a:rPr>
+              <a:t>Implemented both </a:t>
+            </a:r>
+            <a:r>
+              <a:rPr lang="en-US" sz="1400" dirty="0" err="1">
+                <a:latin typeface="Tahoma" panose="020B0604030504040204" pitchFamily="34" charset="0"/>
+                <a:ea typeface="Tahoma" panose="020B0604030504040204" pitchFamily="34" charset="0"/>
+                <a:cs typeface="Tahoma" panose="020B0604030504040204" pitchFamily="34" charset="0"/>
+              </a:rPr>
+              <a:t>NoSQL</a:t>
+            </a:r>
+            <a:r>
+              <a:rPr lang="en-US" sz="1400" dirty="0">
+                <a:latin typeface="Tahoma" panose="020B0604030504040204" pitchFamily="34" charset="0"/>
+                <a:ea typeface="Tahoma" panose="020B0604030504040204" pitchFamily="34" charset="0"/>
+                <a:cs typeface="Tahoma" panose="020B0604030504040204" pitchFamily="34" charset="0"/>
+              </a:rPr>
+              <a:t> and relational storage for flexibility and structured </a:t>
+            </a:r>
+            <a:r>
+              <a:rPr lang="en-US" sz="1400" dirty="0" smtClean="0">
+                <a:latin typeface="Tahoma" panose="020B0604030504040204" pitchFamily="34" charset="0"/>
+                <a:ea typeface="Tahoma" panose="020B0604030504040204" pitchFamily="34" charset="0"/>
+                <a:cs typeface="Tahoma" panose="020B0604030504040204" pitchFamily="34" charset="0"/>
+              </a:rPr>
+              <a:t>querying</a:t>
+            </a:r>
+            <a:endParaRPr lang="en-US" sz="1200" dirty="0" smtClean="0">
+              <a:latin typeface="Tahoma" panose="020B0604030504040204" pitchFamily="34" charset="0"/>
+              <a:ea typeface="Tahoma" panose="020B0604030504040204" pitchFamily="34" charset="0"/>
+              <a:cs typeface="Tahoma" panose="020B0604030504040204" pitchFamily="34" charset="0"/>
+            </a:endParaRPr>
+          </a:p>
+          <a:p>
             <a:endParaRPr lang="en-US" sz="1600" dirty="0">
               <a:latin typeface="Tahoma" panose="020B0604030504040204" pitchFamily="34" charset="0"/>
               <a:ea typeface="Tahoma" panose="020B0604030504040204" pitchFamily="34" charset="0"/>
@@ -9768,7 +9819,7 @@
         </p:blipFill>
         <p:spPr>
           <a:xfrm>
-            <a:off x="7916553" y="3274973"/>
+            <a:off x="8972550" y="3355185"/>
             <a:ext cx="3075297" cy="3478252"/>
           </a:xfrm>
           <a:prstGeom prst="rect">
@@ -10637,82 +10688,172 @@
           </a:xfrm>
         </p:spPr>
         <p:txBody>
-          <a:bodyPr/>
+          <a:bodyPr>
+            <a:normAutofit/>
+          </a:bodyPr>
           <a:lstStyle/>
           <a:p>
             <a:r>
-              <a:rPr lang="en-US" dirty="0" smtClean="0"/>
+              <a:rPr lang="en-US" sz="1600" dirty="0">
+                <a:latin typeface="Tahoma" panose="020B0604030504040204" pitchFamily="34" charset="0"/>
+                <a:ea typeface="Tahoma" panose="020B0604030504040204" pitchFamily="34" charset="0"/>
+                <a:cs typeface="Tahoma" panose="020B0604030504040204" pitchFamily="34" charset="0"/>
+              </a:rPr>
               <a:t>Unit Testing</a:t>
             </a:r>
           </a:p>
           <a:p>
-            <a:pPr lvl="1"/>
+            <a:pPr marL="685800" lvl="2">
+              <a:spcBef>
+                <a:spcPts val="1000"/>
+              </a:spcBef>
+            </a:pPr>
             <a:r>
-              <a:rPr lang="en-US" dirty="0" err="1"/>
+              <a:rPr lang="en-US" sz="1400" dirty="0" err="1">
+                <a:latin typeface="Tahoma" panose="020B0604030504040204" pitchFamily="34" charset="0"/>
+                <a:ea typeface="Tahoma" panose="020B0604030504040204" pitchFamily="34" charset="0"/>
+                <a:cs typeface="Tahoma" panose="020B0604030504040204" pitchFamily="34" charset="0"/>
+              </a:rPr>
               <a:t>test_feature_engineering</a:t>
             </a:r>
             <a:r>
-              <a:rPr lang="en-US" dirty="0"/>
+              <a:rPr lang="en-US" sz="1400" dirty="0">
+                <a:latin typeface="Tahoma" panose="020B0604030504040204" pitchFamily="34" charset="0"/>
+                <a:ea typeface="Tahoma" panose="020B0604030504040204" pitchFamily="34" charset="0"/>
+                <a:cs typeface="Tahoma" panose="020B0604030504040204" pitchFamily="34" charset="0"/>
+              </a:rPr>
               <a:t>(self)</a:t>
             </a:r>
           </a:p>
           <a:p>
-            <a:pPr lvl="1"/>
+            <a:pPr marL="685800" lvl="2">
+              <a:spcBef>
+                <a:spcPts val="1000"/>
+              </a:spcBef>
+            </a:pPr>
             <a:r>
-              <a:rPr lang="en-US" dirty="0" err="1"/>
+              <a:rPr lang="en-US" sz="1400" dirty="0" err="1" smtClean="0">
+                <a:latin typeface="Tahoma" panose="020B0604030504040204" pitchFamily="34" charset="0"/>
+                <a:ea typeface="Tahoma" panose="020B0604030504040204" pitchFamily="34" charset="0"/>
+                <a:cs typeface="Tahoma" panose="020B0604030504040204" pitchFamily="34" charset="0"/>
+              </a:rPr>
               <a:t>test_encoding</a:t>
             </a:r>
             <a:r>
-              <a:rPr lang="en-US" dirty="0"/>
-              <a:t>(self)</a:t>
+              <a:rPr lang="en-US" sz="1400" dirty="0" smtClean="0">
+                <a:latin typeface="Tahoma" panose="020B0604030504040204" pitchFamily="34" charset="0"/>
+                <a:ea typeface="Tahoma" panose="020B0604030504040204" pitchFamily="34" charset="0"/>
+                <a:cs typeface="Tahoma" panose="020B0604030504040204" pitchFamily="34" charset="0"/>
+              </a:rPr>
+              <a:t>(self</a:t>
             </a:r>
-          </a:p>
-          <a:p>
-            <a:pPr lvl="1"/>
             <a:r>
-              <a:rPr lang="en-US" dirty="0" err="1"/>
+              <a:rPr lang="en-US" sz="1400" dirty="0">
+                <a:latin typeface="Tahoma" panose="020B0604030504040204" pitchFamily="34" charset="0"/>
+                <a:ea typeface="Tahoma" panose="020B0604030504040204" pitchFamily="34" charset="0"/>
+                <a:cs typeface="Tahoma" panose="020B0604030504040204" pitchFamily="34" charset="0"/>
+              </a:rPr>
+              <a:t>)</a:t>
+            </a:r>
+          </a:p>
+          <a:p>
+            <a:pPr marL="685800" lvl="2">
+              <a:spcBef>
+                <a:spcPts val="1000"/>
+              </a:spcBef>
+            </a:pPr>
+            <a:r>
+              <a:rPr lang="en-US" sz="1400" dirty="0" err="1">
+                <a:latin typeface="Tahoma" panose="020B0604030504040204" pitchFamily="34" charset="0"/>
+                <a:ea typeface="Tahoma" panose="020B0604030504040204" pitchFamily="34" charset="0"/>
+                <a:cs typeface="Tahoma" panose="020B0604030504040204" pitchFamily="34" charset="0"/>
+              </a:rPr>
               <a:t>test_scaling</a:t>
             </a:r>
             <a:r>
-              <a:rPr lang="en-US" dirty="0"/>
+              <a:rPr lang="en-US" sz="1400" dirty="0">
+                <a:latin typeface="Tahoma" panose="020B0604030504040204" pitchFamily="34" charset="0"/>
+                <a:ea typeface="Tahoma" panose="020B0604030504040204" pitchFamily="34" charset="0"/>
+                <a:cs typeface="Tahoma" panose="020B0604030504040204" pitchFamily="34" charset="0"/>
+              </a:rPr>
               <a:t>(self</a:t>
             </a:r>
             <a:r>
-              <a:rPr lang="en-US" dirty="0" smtClean="0"/>
+              <a:rPr lang="en-US" sz="1400" dirty="0">
+                <a:latin typeface="Tahoma" panose="020B0604030504040204" pitchFamily="34" charset="0"/>
+                <a:ea typeface="Tahoma" panose="020B0604030504040204" pitchFamily="34" charset="0"/>
+                <a:cs typeface="Tahoma" panose="020B0604030504040204" pitchFamily="34" charset="0"/>
+              </a:rPr>
               <a:t>)</a:t>
             </a:r>
           </a:p>
           <a:p>
             <a:r>
-              <a:rPr lang="en-US" dirty="0" smtClean="0"/>
+              <a:rPr lang="en-US" sz="1600" dirty="0">
+                <a:latin typeface="Tahoma" panose="020B0604030504040204" pitchFamily="34" charset="0"/>
+                <a:ea typeface="Tahoma" panose="020B0604030504040204" pitchFamily="34" charset="0"/>
+                <a:cs typeface="Tahoma" panose="020B0604030504040204" pitchFamily="34" charset="0"/>
+              </a:rPr>
               <a:t>Integration Testing</a:t>
             </a:r>
           </a:p>
           <a:p>
-            <a:pPr lvl="1"/>
+            <a:pPr marL="685800" lvl="2">
+              <a:spcBef>
+                <a:spcPts val="1000"/>
+              </a:spcBef>
+            </a:pPr>
             <a:r>
-              <a:rPr lang="en-US" dirty="0" err="1"/>
+              <a:rPr lang="en-US" sz="1400" dirty="0" err="1">
+                <a:latin typeface="Tahoma" panose="020B0604030504040204" pitchFamily="34" charset="0"/>
+                <a:ea typeface="Tahoma" panose="020B0604030504040204" pitchFamily="34" charset="0"/>
+                <a:cs typeface="Tahoma" panose="020B0604030504040204" pitchFamily="34" charset="0"/>
+              </a:rPr>
               <a:t>test_full_pipeline</a:t>
             </a:r>
             <a:r>
-              <a:rPr lang="en-US" dirty="0"/>
+              <a:rPr lang="en-US" sz="1400" dirty="0">
+                <a:latin typeface="Tahoma" panose="020B0604030504040204" pitchFamily="34" charset="0"/>
+                <a:ea typeface="Tahoma" panose="020B0604030504040204" pitchFamily="34" charset="0"/>
+                <a:cs typeface="Tahoma" panose="020B0604030504040204" pitchFamily="34" charset="0"/>
+              </a:rPr>
               <a:t>(self)</a:t>
             </a:r>
           </a:p>
           <a:p>
-            <a:pPr lvl="1"/>
+            <a:pPr marL="685800" lvl="2">
+              <a:spcBef>
+                <a:spcPts val="1000"/>
+              </a:spcBef>
+            </a:pPr>
             <a:r>
-              <a:rPr lang="en-US" dirty="0" err="1"/>
+              <a:rPr lang="en-US" sz="1400" dirty="0" err="1">
+                <a:latin typeface="Tahoma" panose="020B0604030504040204" pitchFamily="34" charset="0"/>
+                <a:ea typeface="Tahoma" panose="020B0604030504040204" pitchFamily="34" charset="0"/>
+                <a:cs typeface="Tahoma" panose="020B0604030504040204" pitchFamily="34" charset="0"/>
+              </a:rPr>
               <a:t>test_full_pipeline_noerror</a:t>
             </a:r>
             <a:r>
-              <a:rPr lang="en-US" dirty="0"/>
+              <a:rPr lang="en-US" sz="1400" dirty="0">
+                <a:latin typeface="Tahoma" panose="020B0604030504040204" pitchFamily="34" charset="0"/>
+                <a:ea typeface="Tahoma" panose="020B0604030504040204" pitchFamily="34" charset="0"/>
+                <a:cs typeface="Tahoma" panose="020B0604030504040204" pitchFamily="34" charset="0"/>
+              </a:rPr>
               <a:t>(self)</a:t>
             </a:r>
           </a:p>
           <a:p>
-            <a:pPr lvl="1"/>
-            <a:endParaRPr lang="en-US" dirty="0"/>
+            <a:pPr marL="228600" lvl="1">
+              <a:spcBef>
+                <a:spcPts val="1000"/>
+              </a:spcBef>
+            </a:pPr>
+            <a:endParaRPr lang="en-US" sz="1600" dirty="0">
+              <a:latin typeface="Tahoma" panose="020B0604030504040204" pitchFamily="34" charset="0"/>
+              <a:ea typeface="Tahoma" panose="020B0604030504040204" pitchFamily="34" charset="0"/>
+              <a:cs typeface="Tahoma" panose="020B0604030504040204" pitchFamily="34" charset="0"/>
+            </a:endParaRPr>
           </a:p>
         </p:txBody>
       </p:sp>
@@ -12464,6 +12605,147 @@
           <a:lstStyle/>
           <a:p>
             <a:r>
+              <a:rPr lang="en-US" sz="2800" b="1" dirty="0" smtClean="0">
+                <a:solidFill>
+                  <a:srgbClr val="002060"/>
+                </a:solidFill>
+                <a:latin typeface="Tahoma" panose="020B0604030504040204" pitchFamily="34" charset="0"/>
+                <a:ea typeface="Tahoma" panose="020B0604030504040204" pitchFamily="34" charset="0"/>
+                <a:cs typeface="Tahoma" panose="020B0604030504040204" pitchFamily="34" charset="0"/>
+              </a:rPr>
+              <a:t>COMPLEXITY OF THE PROJECT</a:t>
+            </a:r>
+            <a:endParaRPr lang="en-US" sz="2800" dirty="0"/>
+          </a:p>
+        </p:txBody>
+      </p:sp>
+      <p:sp>
+        <p:nvSpPr>
+          <p:cNvPr id="3" name="Content Placeholder 2"/>
+          <p:cNvSpPr>
+            <a:spLocks noGrp="1"/>
+          </p:cNvSpPr>
+          <p:nvPr>
+            <p:ph idx="1"/>
+          </p:nvPr>
+        </p:nvSpPr>
+        <p:spPr>
+          <a:xfrm>
+            <a:off x="838200" y="1276985"/>
+            <a:ext cx="10515600" cy="4351338"/>
+          </a:xfrm>
+        </p:spPr>
+        <p:txBody>
+          <a:bodyPr>
+            <a:normAutofit/>
+          </a:bodyPr>
+          <a:lstStyle/>
+          <a:p>
+            <a:r>
+              <a:rPr lang="en-US" sz="1600" dirty="0">
+                <a:latin typeface="Tahoma" panose="020B0604030504040204" pitchFamily="34" charset="0"/>
+                <a:ea typeface="Tahoma" panose="020B0604030504040204" pitchFamily="34" charset="0"/>
+                <a:cs typeface="Tahoma" panose="020B0604030504040204" pitchFamily="34" charset="0"/>
+              </a:rPr>
+              <a:t>Collecting data from multiple resources</a:t>
+            </a:r>
+          </a:p>
+          <a:p>
+            <a:r>
+              <a:rPr lang="en-US" sz="1600" dirty="0">
+                <a:latin typeface="Tahoma" panose="020B0604030504040204" pitchFamily="34" charset="0"/>
+                <a:ea typeface="Tahoma" panose="020B0604030504040204" pitchFamily="34" charset="0"/>
+                <a:cs typeface="Tahoma" panose="020B0604030504040204" pitchFamily="34" charset="0"/>
+              </a:rPr>
+              <a:t>Custom feature engineering including a weighted popularity score</a:t>
+            </a:r>
+          </a:p>
+          <a:p>
+            <a:r>
+              <a:rPr lang="en-US" sz="1600" dirty="0">
+                <a:latin typeface="Tahoma" panose="020B0604030504040204" pitchFamily="34" charset="0"/>
+                <a:ea typeface="Tahoma" panose="020B0604030504040204" pitchFamily="34" charset="0"/>
+                <a:cs typeface="Tahoma" panose="020B0604030504040204" pitchFamily="34" charset="0"/>
+              </a:rPr>
+              <a:t>Full preprocessing pipeline with cat codes and scaling</a:t>
+            </a:r>
+          </a:p>
+          <a:p>
+            <a:r>
+              <a:rPr lang="en-US" sz="1600" dirty="0">
+                <a:latin typeface="Tahoma" panose="020B0604030504040204" pitchFamily="34" charset="0"/>
+                <a:ea typeface="Tahoma" panose="020B0604030504040204" pitchFamily="34" charset="0"/>
+                <a:cs typeface="Tahoma" panose="020B0604030504040204" pitchFamily="34" charset="0"/>
+              </a:rPr>
+              <a:t>Hybrid database design using </a:t>
+            </a:r>
+            <a:r>
+              <a:rPr lang="en-US" sz="1600" dirty="0" err="1">
+                <a:latin typeface="Tahoma" panose="020B0604030504040204" pitchFamily="34" charset="0"/>
+                <a:ea typeface="Tahoma" panose="020B0604030504040204" pitchFamily="34" charset="0"/>
+                <a:cs typeface="Tahoma" panose="020B0604030504040204" pitchFamily="34" charset="0"/>
+              </a:rPr>
+              <a:t>MongoDB</a:t>
+            </a:r>
+            <a:r>
+              <a:rPr lang="en-US" sz="1600" dirty="0">
+                <a:latin typeface="Tahoma" panose="020B0604030504040204" pitchFamily="34" charset="0"/>
+                <a:ea typeface="Tahoma" panose="020B0604030504040204" pitchFamily="34" charset="0"/>
+                <a:cs typeface="Tahoma" panose="020B0604030504040204" pitchFamily="34" charset="0"/>
+              </a:rPr>
+              <a:t> and SQLite</a:t>
+            </a:r>
+          </a:p>
+        </p:txBody>
+      </p:sp>
+    </p:spTree>
+    <p:extLst>
+      <p:ext uri="{BB962C8B-B14F-4D97-AF65-F5344CB8AC3E}">
+        <p14:creationId xmlns:p14="http://schemas.microsoft.com/office/powerpoint/2010/main" val="557934619"/>
+      </p:ext>
+    </p:extLst>
+  </p:cSld>
+  <p:clrMapOvr>
+    <a:masterClrMapping/>
+  </p:clrMapOvr>
+</p:sld>
+</file>
+
+<file path=ppt/slides/slide15.xml><?xml version="1.0" encoding="utf-8"?>
+<p:sld xmlns:a="http://schemas.openxmlformats.org/drawingml/2006/main" xmlns:r="http://schemas.openxmlformats.org/officeDocument/2006/relationships" xmlns:p="http://schemas.openxmlformats.org/presentationml/2006/main">
+  <p:cSld>
+    <p:spTree>
+      <p:nvGrpSpPr>
+        <p:cNvPr id="1" name=""/>
+        <p:cNvGrpSpPr/>
+        <p:nvPr/>
+      </p:nvGrpSpPr>
+      <p:grpSpPr>
+        <a:xfrm>
+          <a:off x="0" y="0"/>
+          <a:ext cx="0" cy="0"/>
+          <a:chOff x="0" y="0"/>
+          <a:chExt cx="0" cy="0"/>
+        </a:xfrm>
+      </p:grpSpPr>
+      <p:sp>
+        <p:nvSpPr>
+          <p:cNvPr id="2" name="Title 1"/>
+          <p:cNvSpPr>
+            <a:spLocks noGrp="1"/>
+          </p:cNvSpPr>
+          <p:nvPr>
+            <p:ph type="title"/>
+          </p:nvPr>
+        </p:nvSpPr>
+        <p:spPr/>
+        <p:txBody>
+          <a:bodyPr>
+            <a:normAutofit/>
+          </a:bodyPr>
+          <a:lstStyle/>
+          <a:p>
+            <a:r>
               <a:rPr lang="en-US" sz="2800" b="1" dirty="0">
                 <a:solidFill>
                   <a:srgbClr val="002060"/>
@@ -13321,7 +13603,7 @@
 </p:sld>
 </file>
 
-<file path=ppt/slides/slide15.xml><?xml version="1.0" encoding="utf-8"?>
+<file path=ppt/slides/slide16.xml><?xml version="1.0" encoding="utf-8"?>
 <p:sld xmlns:a="http://schemas.openxmlformats.org/drawingml/2006/main" xmlns:r="http://schemas.openxmlformats.org/officeDocument/2006/relationships" xmlns:p="http://schemas.openxmlformats.org/presentationml/2006/main">
   <p:cSld>
     <p:spTree>
@@ -14122,15 +14404,15 @@
         </p:nvSpPr>
         <p:spPr>
           <a:xfrm>
-            <a:off x="2976283" y="2321877"/>
-            <a:ext cx="6096000" cy="1107996"/>
+            <a:off x="2445059" y="2330585"/>
+            <a:ext cx="7961683" cy="1446550"/>
           </a:xfrm>
           <a:prstGeom prst="rect">
             <a:avLst/>
           </a:prstGeom>
         </p:spPr>
         <p:txBody>
-          <a:bodyPr>
+          <a:bodyPr wrap="square">
             <a:spAutoFit/>
           </a:bodyPr>
           <a:lstStyle/>
@@ -14144,7 +14426,7 @@
               </a:tabLst>
             </a:pPr>
             <a:r>
-              <a:rPr lang="en-US" sz="6600" b="1" dirty="0" smtClean="0">
+              <a:rPr lang="en-US" sz="8800" b="1" dirty="0" smtClean="0">
                 <a:solidFill>
                   <a:srgbClr val="002060"/>
                 </a:solidFill>
@@ -14154,7 +14436,7 @@
               </a:rPr>
               <a:t>THANK YOU!</a:t>
             </a:r>
-            <a:endParaRPr lang="fr-FR" sz="6600" b="1" dirty="0">
+            <a:endParaRPr lang="fr-FR" sz="8800" b="1" dirty="0">
               <a:solidFill>
                 <a:srgbClr val="002060"/>
               </a:solidFill>

</xml_diff>